<commit_message>
Full spoken script: in speaker-notes.md and injected into pptx notes
~1100 spoken words (~9 min at talking pace), slide by slide, with stage
cues.  The pptx was edited IN PLACE with python-pptx - slides and the
team's hand edits (member names) are untouched; only the notes frames
were rewritten.

Co-Authored-By: Claude Fable 5 <noreply@anthropic.com>
</commit_message>
<xml_diff>
--- a/docs/presentation.pptx
+++ b/docs/presentation.pptx
@@ -294,8 +294,19 @@
           <a:lstStyle/>
           <a:p>
             <a:r>
-              <a:rPr lang="en-US" dirty="0"/>
-              <a:t>~30s. One presenter opens. Replace member placeholders with real names. The board on the right is the Pulles (2021) example puzzle with its unique solution, drawn by our own renderer's conventions.</a:t>
+              <a:t>[~30 s]</a:t>
+            </a:r>
+          </a:p>
+          <a:p/>
+          <a:p>
+            <a:r>
+              <a:t>Good morning. We are [say your names]. Our project is LightUp — also known as Akari — a Japanese logic puzzle. We built the game itself, and then made five different AI solvers compete on it. The board you see here is a published puzzle, solved by our own system. Let me start with the rules.</a:t>
+            </a:r>
+          </a:p>
+          <a:p/>
+          <a:p>
+            <a:r>
+              <a:t>(Cue: One presenter opens; keep it moving.)</a:t>
             </a:r>
           </a:p>
         </p:txBody>
@@ -381,8 +392,13 @@
           <a:lstStyle/>
           <a:p>
             <a:r>
-              <a:rPr lang="en-US" dirty="0"/>
-              <a:t>~1 min. The beyond-the-obvious slide. The headline: our density presets predict difficulty for HUMANS (deduction chains), not for solvers - sparse boards have many solutions and finding any one is easy. Tie back to the uniqueness discussion. Calibrating difficulty by measured effort is named future work.</a:t>
+              <a:t>[~1 min]</a:t>
+            </a:r>
+          </a:p>
+          <a:p/>
+          <a:p>
+            <a:r>
+              <a:t>What makes an instance hard? Here we got a genuine surprise. Our hard preset — few walls, few clues — is hard for humans, but often faster for solvers: fewer clues means more valid solutions, and finding any one of them is easier. Hill climbing shows the mirror image: at fourteen-by-fourteen it solved nothing at easy or medium density, but sometimes cracked the sparse boards — dense clues create exactly the local optima that trap it. So our difficulty presets model human difficulty, not search difficulty — and calibrating them by measured effort is future work.</a:t>
             </a:r>
           </a:p>
         </p:txBody>
@@ -468,8 +484,19 @@
           <a:lstStyle/>
           <a:p>
             <a:r>
-              <a:rPr lang="en-US" dirty="0"/>
-              <a:t>ONE sentence, ~20s: 'We re-ran the entire sweep with double the budget - almost nothing changed, and hill climbing gained exactly zero - so the solver ranking is structural, not an artifact of the timeout.' If asked in Q&amp;A: we predicted the outcomes before running (full unchanged, hc zero); the one miss was SA, which we expected to gain more - exponential problems shrug at factors of two.</a:t>
+              <a:t>[~20 s]</a:t>
+            </a:r>
+          </a:p>
+          <a:p/>
+          <a:p>
+            <a:r>
+              <a:t>One robustness check: we re-ran the entire sweep with double the budget — almost nothing changed, and hill climbing gained exactly zero — so the ranking you have seen is structural, not an artifact of the timeout.</a:t>
+            </a:r>
+          </a:p>
+          <a:p/>
+          <a:p>
+            <a:r>
+              <a:t>(Cue: One sentence, then move on. Q&amp;A backup: predictions were made before the run; the one miss was SA (expected bigger gains) — exponential problems shrug at factors of two.)</a:t>
             </a:r>
           </a:p>
         </p:txBody>
@@ -555,8 +582,19 @@
           <a:lstStyle/>
           <a:p>
             <a:r>
-              <a:rPr lang="en-US" dirty="0"/>
-              <a:t>~45s. Every claim here is a measured number from experiments/results/results.csv (overall: SA 45/75 = 60%, HC 21/75 = 28%; hard-only: 19/25 vs 11/25). All four members should have spoken by now (equal input is graded).</a:t>
+              <a:t>[~45 s]</a:t>
+            </a:r>
+          </a:p>
+          <a:p/>
+          <a:p>
+            <a:r>
+              <a:t>To conclude. Inference was the story: full propagation solved everything we generated, and cracked the reference puzzle without any search. Fewer nodes is not the same as less time. Simulated annealing beats hill climbing, confirming prior work — and hill climbing's failures are structural, stuck one step from the goal. Sparse boards turned out easier for solvers than for humans. Future work: generating unique-solution puzzles, arc consistency, and difficulty calibration. Thank you — we are happy to take questions.</a:t>
+            </a:r>
+          </a:p>
+          <a:p/>
+          <a:p>
+            <a:r>
+              <a:t>(Cue: All four members should have spoken by now.)</a:t>
             </a:r>
           </a:p>
         </p:txBody>
@@ -642,8 +680,13 @@
           <a:lstStyle/>
           <a:p>
             <a:r>
-              <a:rPr lang="en-US" dirty="0"/>
-              <a:t>Not spoken — present for completeness and Q&amp;A.</a:t>
+              <a:t>[not spoken]</a:t>
+            </a:r>
+          </a:p>
+          <a:p/>
+          <a:p>
+            <a:r>
+              <a:t>(Cue: Present for completeness and Q&amp;A only.)</a:t>
             </a:r>
           </a:p>
         </p:txBody>
@@ -729,8 +772,19 @@
           <a:lstStyle/>
           <a:p>
             <a:r>
-              <a:rPr lang="en-US" dirty="0"/>
-              <a:t>~1 min. State the rules quickly with the example. Do NOT dwell — the course requires only a brief problem statement. Mention the uniqueness note; it returns in the analysis.</a:t>
+              <a:t>[~1 min]</a:t>
+            </a:r>
+          </a:p>
+          <a:p/>
+          <a:p>
+            <a:r>
+              <a:t>LightUp has three rules. You place light bulbs on white cells. Rule one: every white cell must be lit — a bulb lights its whole row and column until a wall blocks the light. Rule two: no bulb may shine on another bulb. Rule three: a numbered wall must have exactly that many bulbs next to it — exactly, not at most. In this small example the corner two forces both of its neighbors, and one more bulb finishes the board. One detail worth remembering: nothing in the rules says a puzzle has only one solution — uniqueness is a publishing convention, and that detail will come back in our results.</a:t>
+            </a:r>
+          </a:p>
+          <a:p/>
+          <a:p>
+            <a:r>
+              <a:t>(Cue: Point at the 3x3 while explaining. Do not dwell.)</a:t>
             </a:r>
           </a:p>
         </p:txBody>
@@ -816,8 +870,19 @@
           <a:lstStyle/>
           <a:p>
             <a:r>
-              <a:rPr lang="en-US" dirty="0"/>
-              <a:t>~1 min. The three cards are the topic-choice justification. Keep the prior-work strip to two sentences — the course explicitly says existing approaches should be mentioned only very briefly.</a:t>
+              <a:t>[~1 min]</a:t>
+            </a:r>
+          </a:p>
+          <a:p/>
+          <a:p>
+            <a:r>
+              <a:t>Why is this a good AI problem? Three reasons. First, it is NP-complete — proven by reduction from circuit satisfiability — so no algorithm can be expected to scale forever, and cleverness has to earn its keep. Second, it is a very clean constraint-satisfaction problem: one yes-or-no variable per white cell. Third, it scales: our generator produces boards from three-by-three up to twenty-five-by-twenty-five with tunable difficulty, which gives us unlimited test data. Earlier work solved LightUp with SAT encodings, with local search, and with evolutionary algorithms — we compare directly against the local-search results later.</a:t>
+            </a:r>
+          </a:p>
+          <a:p/>
+          <a:p>
+            <a:r>
+              <a:t>(Cue: Prior work stays at one sentence — the course asks for brevity here.)</a:t>
             </a:r>
           </a:p>
         </p:txBody>
@@ -903,8 +968,19 @@
           <a:lstStyle/>
           <a:p>
             <a:r>
-              <a:rPr lang="en-US" dirty="0"/>
-              <a:t>~45s. One slide of formalism, no more. Do NOT explain what a CSP or backtracking is — covered in the course. The 'lit is derived' line preempts a common Q&amp;A question about the domain.</a:t>
+              <a:t>[~45 s]</a:t>
+            </a:r>
+          </a:p>
+          <a:p/>
+          <a:p>
+            <a:r>
+              <a:t>Our formulation: one binary variable per white cell — bulb or no bulb. The three rules become three families of counting constraints: every cell's line of sight must contain at least one bulb; every wall-free segment, at most one; every numbered wall, exactly its number. One design decision worth mentioning: 'lit' is not a variable. Whether a cell is lit follows entirely from where the bulbs are, so storing it as a state would only inflate the search space.</a:t>
+            </a:r>
+          </a:p>
+          <a:p/>
+          <a:p>
+            <a:r>
+              <a:t>(Cue: Do not explain what a CSP is — covered in the course.)</a:t>
             </a:r>
           </a:p>
         </p:txBody>
@@ -990,8 +1066,19 @@
           <a:lstStyle/>
           <a:p>
             <a:r>
-              <a:rPr lang="en-US" dirty="0"/>
-              <a:t>~1 min. The experiment design in one picture: each arrow on the left changes exactly one thing, so differences in the stats are attributable. Right column is the cross-paradigm comparison.</a:t>
+              <a:t>[~1 min]</a:t>
+            </a:r>
+          </a:p>
+          <a:p/>
+          <a:p>
+            <a:r>
+              <a:t>We implemented five solvers in two families. On the left, complete search. Plain backtracking is the baseline — it re-checks the whole board at every step. Forward checking adds memory: placing a bulb immediately rules out every cell it sees. Full inference adds deduction, applied over and over: a satisfied clue blocks its remaining neighbors, a clue that needs all its remaining cells forces them, and a cell with only one possible light source left forces that source. Those are exactly the moves a human player makes. On the right, local search: hill climbing and simulated annealing start from a complete random placement and repair it, guided by a score that counts rule violations — zero violations means solved. Every solver reports the same statistics, so the comparison is fair.</a:t>
+            </a:r>
+          </a:p>
+          <a:p/>
+          <a:p>
+            <a:r>
+              <a:t>(Cue: This slide is the experiment design in one picture.)</a:t>
             </a:r>
           </a:p>
         </p:txBody>
@@ -1077,8 +1164,19 @@
           <a:lstStyle/>
           <a:p>
             <a:r>
-              <a:rPr lang="en-US" dirty="0"/>
-              <a:t>~45s. The screenshot is the naive solver mid-replay on a 10x10: red frame = conflict at (9,7), green digits = satisfied clues, status bar streams the event counter and search stats. Demo bait: if time allows in Q&amp;A, a 20-second live solve in the GUI is worth more than this slide. Do not show code.</a:t>
+              <a:t>[~45 s]</a:t>
+            </a:r>
+          </a:p>
+          <a:p/>
+          <a:p>
+            <a:r>
+              <a:t>Everything is observable. This is our game — you can play it yourself, including the X marks human players use for notes. The same window animates any solver: in this screenshot the naive solver is mid-search on a ten-by-ten — the red frame is a conflict it just hit, and the status bar shows it has already tried eighty-eight thousand nodes. This replay tool is how we debugged the solvers, and honestly, how we came to understand them.</a:t>
+            </a:r>
+          </a:p>
+          <a:p/>
+          <a:p>
+            <a:r>
+              <a:t>(Cue: If Q&amp;A time allows, a 20-second live solve beats this slide — have the game open in a background window. Never show code.)</a:t>
             </a:r>
           </a:p>
         </p:txBody>
@@ -1164,8 +1262,13 @@
           <a:lstStyle/>
           <a:p>
             <a:r>
-              <a:rPr lang="en-US" dirty="0"/>
-              <a:t>~45s. Fill the two [CONFIRM] blanks once the experiment harness is final. The bottom principle matters in Q&amp;A: multi-solution instances make answer-comparison invalid as a correctness test.</a:t>
+              <a:t>[~45 s]</a:t>
+            </a:r>
+          </a:p>
+          <a:p/>
+          <a:p>
+            <a:r>
+              <a:t>The experiment: five board sizes from seven to twenty-five, three difficulty presets from clue-dense to sparse, five seeded instances per combination — seventy-five unique puzzles — and every solver gets identical puzzles with a five-second budget: three hundred seventy-five runs. Everything is seeded, so every number that follows is reproducible. And one principle: we judge correctness by the rules themselves, never by comparing to a stored answer, because a board can have several legal solutions.</a:t>
             </a:r>
           </a:p>
         </p:txBody>
@@ -1251,8 +1354,19 @@
           <a:lstStyle/>
           <a:p>
             <a:r>
-              <a:rPr lang="en-US" dirty="0"/>
-              <a:t>~1.5 min. THE core slide. Say the numbers out loud: naive 308 nodes on the 7x7, forward checking 12, full inference ZERO - the published puzzle is solved by deduction alone, which is exactly what publishers curate for. Then the scaling panels: 1-2 orders of magnitude between naive and the smart variants. Close with the nodes-vs-time nuance - fewer nodes is not automatically less time.</a:t>
+              <a:t>[~1.5 min]</a:t>
+            </a:r>
+          </a:p>
+          <a:p/>
+          <a:p>
+            <a:r>
+              <a:t>So, what does inference buy? Two headline numbers. On the published seven-by-seven, the naive solver needs three hundred and eight search nodes. Forward checking needs twelve. Full inference needs zero — the puzzle is solved entirely by deduction, no search at all. And that makes sense: publishers design puzzles that humans can deduce. Across the whole sweep, full inference solved all seventy-five instances — the only solver with a perfect record. The charts show the scaling: the naive curve leaves the picture after eighteen-by-eighteen — it solves nothing at twenty-five — while both smart variants stay one to two orders of magnitude lower. One honest nuance: full inference uses about half the nodes of forward checking, yet forward checking is slightly faster per board at the largest sizes, because propagation costs time at every node. Fewer nodes is not automatically less time.</a:t>
+            </a:r>
+          </a:p>
+          <a:p/>
+          <a:p>
+            <a:r>
+              <a:t>(Cue: THE core slide. Say 308 -&gt; 12 -&gt; 0 slowly.)</a:t>
             </a:r>
           </a:p>
         </p:txBody>
@@ -1338,8 +1452,19 @@
           <a:lstStyle/>
           <a:p>
             <a:r>
-              <a:rPr lang="en-US" dirty="0"/>
-              <a:t>~1.5 min. Cross-paradigm comparison. Lead with SA vs HC (the Perera reproduction), then the one-violation-away story - it is the local-optimum concept made concrete. End on the honest framing: on these sizes complete search wins; incompleteness is the structural caveat.</a:t>
+              <a:t>[~1.5 min]</a:t>
+            </a:r>
+          </a:p>
+          <a:p/>
+          <a:p>
+            <a:r>
+              <a:t>Now the other paradigm. This chart shows the solve rate within five seconds on hard instances. Simulated annealing clearly beats hill climbing everywhere — nineteen out of twenty-five versus eleven — which independently reproduces the published result of Perera and colleagues. Why does hill climbing fail? It gets stuck. In one twenty-second run it restarted twelve and a half thousand times and ended every attempt exactly one violation away from the goal. That is a local optimum in its purest form — and annealing's willingness to temporarily accept worse states is precisely what escapes it. Overall, though, within this budget, complete search with inference dominated local search at every size we tested. And one structural caveat: local search can never prove a board unsolvable.</a:t>
+            </a:r>
+          </a:p>
+          <a:p/>
+          <a:p>
+            <a:r>
+              <a:t>(Cue: The one-violation-away story is the local-optimum concept made concrete — deliver it as a story.)</a:t>
             </a:r>
           </a:p>
         </p:txBody>

</xml_diff>

<commit_message>
Fill team names: script intro, speaker assignment, pptx notes
Anna Gasparyan (slides 1-4), Ani Baghumyan (5-8), Izabella Atajanyan
(9-13) - balanced by speaking time.  Slide-1 spoken intro and the
members cue updated in both speaker-notes.md and the pptx notes; the
slides themselves were filled in by the team and are untouched.

Co-Authored-By: Claude Fable 5 <noreply@anthropic.com>
</commit_message>
<xml_diff>
--- a/docs/presentation.pptx
+++ b/docs/presentation.pptx
@@ -300,7 +300,7 @@
           <a:p/>
           <a:p>
             <a:r>
-              <a:t>Good morning. We are [say your names]. Our project is LightUp — also known as Akari — a Japanese logic puzzle. We built the game itself, and then made five different AI solvers compete on it. The board you see here is a published puzzle, solved by our own system. Let me start with the rules.</a:t>
+              <a:t>Good morning. We are Anna Gasparyan, Ani Baghumyan and Izabella Atajanyan. Our project is LightUp — also known as Akari — a Japanese logic puzzle. We built the game itself, and then made five different AI solvers compete on it. The board you see here is a published puzzle, solved by our own system. Let me start with the rules.</a:t>
             </a:r>
           </a:p>
           <a:p/>
@@ -594,7 +594,7 @@
           <a:p/>
           <a:p>
             <a:r>
-              <a:t>(Cue: All four members should have spoken by now.)</a:t>
+              <a:t>(Cue: All three members should have spoken by now.)</a:t>
             </a:r>
           </a:p>
         </p:txBody>

</xml_diff>

<commit_message>
Slide 8: corrected caption and speaker note on fc vs full
The nodes-vs-time nuance is difficulty-dependent, not size-dependent:
full inference always expands ~2x fewer nodes, is up to 35x faster on
clue-dense boards, and slower on the sparse hard boards fig 1 plots.
Caption fits two lines clear of the slide edge.

Co-Authored-By: Claude Fable 5 <noreply@anthropic.com>
</commit_message>
<xml_diff>
--- a/docs/presentation.pptx
+++ b/docs/presentation.pptx
@@ -1360,13 +1360,13 @@
           <a:p/>
           <a:p>
             <a:r>
-              <a:t>So, what does inference buy? Two headline numbers. On the published seven-by-seven, the naive solver needs three hundred and eight search nodes. Forward checking needs twelve. Full inference needs zero — the puzzle is solved entirely by deduction, no search at all. And that makes sense: publishers design puzzles that humans can deduce. Across the whole sweep, full inference solved all seventy-five instances — the only solver with a perfect record. The charts show the scaling: the naive curve leaves the picture after eighteen-by-eighteen — it solves nothing at twenty-five — while both smart variants stay one to two orders of magnitude lower. One honest nuance: full inference uses about half the nodes of forward checking, yet forward checking is slightly faster per board at the largest sizes, because propagation costs time at every node. Fewer nodes is not automatically less time.</a:t>
+              <a:t>So, what does inference buy? Two headline numbers. On the published seven-by-seven, the naive solver needs three hundred and eight search nodes. Forward checking needs twelve. Full inference needs zero — the puzzle is solved entirely by deduction, no search at all. And that makes sense: publishers design puzzles that humans can deduce. Across the whole sweep, full inference solved all seventy-five instances — the only solver with a perfect record. The charts show the scaling: the naive curve leaves the picture after eighteen-by-eighteen — it solves nothing at twenty-five — while both smart variants stay one to two orders of magnitude lower. One honest nuance: full inference always expands about half the nodes of forward checking, but that only saves time when there is something to deduce. On clue-dense boards it is up to thirty-five times faster; on the sparse boards in this chart, forward checking wins, because propagation is an investment paid at every node.</a:t>
             </a:r>
           </a:p>
           <a:p/>
           <a:p>
             <a:r>
-              <a:t>(Cue: THE core slide. Say 308 -&gt; 12 -&gt; 0 slowly.)</a:t>
+              <a:t>(Cue: THE core slide. Say 308 -&gt; 12 -&gt; 0 slowly. If asked why fig 1 favours fc: it plots hard instances only.)</a:t>
             </a:r>
           </a:p>
         </p:txBody>
@@ -9420,7 +9420,7 @@
                 <a:ea typeface="Calibri" pitchFamily="34" charset="-122"/>
                 <a:cs typeface="Calibri" pitchFamily="34" charset="-120"/>
               </a:rPr>
-              <a:t>Naive BT leaves the chart after 18×18 (0 % solved at 25×25). The honest nuance: full inference needs ~2× fewer nodes than forward checking, yet fc is slightly faster per board at large sizes — propagation costs time per node.</a:t>
+              <a:t>Naive BT leaves the chart after 18×18 (0 % solved at 25×25). Full inference always expands ~2× fewer nodes — but that saves time only where there is something to deduce: 35× faster on easy boards, slower on the sparse hard boards plotted here.</a:t>
             </a:r>
             <a:endParaRPr lang="en-US" sz="1150" dirty="0"/>
           </a:p>

</xml_diff>

<commit_message>
Slide 3: replace the idiom with plain wording
Card and spoken script now say that solving time grows exponentially in
the worst case and that a better algorithm pushes the limit further
rather than removing it - concrete, and it sets up the results chapter.
Added a Q&A note for the obvious follow-up (if it is NP-complete, why
was 25x25 solved in 20 ms? NP-completeness is a worst-case statement).

Co-Authored-By: Claude Fable 5 <noreply@anthropic.com>
</commit_message>
<xml_diff>
--- a/docs/presentation.pptx
+++ b/docs/presentation.pptx
@@ -294,18 +294,41 @@
           <a:lstStyle/>
           <a:p>
             <a:r>
+              <a:rPr dirty="0"/>
               <a:t>[~30 s]</a:t>
             </a:r>
           </a:p>
-          <a:p/>
-          <a:p>
-            <a:r>
-              <a:t>Good morning. Our project is LightUp — also known as Akari — a Japanese logic puzzle. We built the game itself, and then made five different AI solvers compete on it. The board you see here is a published puzzle, solved by our own system. Let me start with the rules.</a:t>
-            </a:r>
-          </a:p>
-          <a:p/>
-          <a:p>
-            <a:r>
+          <a:p>
+            <a:endParaRPr dirty="0"/>
+          </a:p>
+          <a:p>
+            <a:r>
+              <a:rPr dirty="0"/>
+              <a:t>Good morning. Our project is </a:t>
+            </a:r>
+            <a:r>
+              <a:rPr dirty="0" err="1"/>
+              <a:t>LightUp</a:t>
+            </a:r>
+            <a:r>
+              <a:rPr dirty="0"/>
+              <a:t> — also known as </a:t>
+            </a:r>
+            <a:r>
+              <a:rPr dirty="0" err="1"/>
+              <a:t>Akari</a:t>
+            </a:r>
+            <a:r>
+              <a:rPr dirty="0"/>
+              <a:t> — a Japanese logic puzzle. We built the game itself, and then made five different AI solvers compete on it. The board you see here is a published puzzle, solved by our own system. Let me start with the rules.</a:t>
+            </a:r>
+          </a:p>
+          <a:p>
+            <a:endParaRPr dirty="0"/>
+          </a:p>
+          <a:p>
+            <a:r>
+              <a:rPr dirty="0"/>
               <a:t>(Cue: One presenter opens; keep it moving.)</a:t>
             </a:r>
           </a:p>
@@ -395,7 +418,9 @@
               <a:t>[~1 min]</a:t>
             </a:r>
           </a:p>
-          <a:p/>
+          <a:p>
+            <a:endParaRPr/>
+          </a:p>
           <a:p>
             <a:r>
               <a:t>What makes an instance hard? Here we got a genuine surprise. Our hard preset — few walls, few clues — is hard for humans, but often faster for solvers: fewer clues means more valid solutions, and finding any one of them is easier. Hill climbing shows the mirror image: at fourteen-by-fourteen it solved nothing at easy or medium density, but sometimes cracked the sparse boards — dense clues create exactly the local optima that trap it. So our difficulty presets model human difficulty, not search difficulty — and calibrating them by measured effort is future work.</a:t>
@@ -487,13 +512,17 @@
               <a:t>[~20 s]</a:t>
             </a:r>
           </a:p>
-          <a:p/>
+          <a:p>
+            <a:endParaRPr/>
+          </a:p>
           <a:p>
             <a:r>
               <a:t>One robustness check: we re-ran the entire sweep with double the budget — almost nothing changed, and hill climbing gained exactly zero — so the ranking you have seen is structural, not an artifact of the timeout.</a:t>
             </a:r>
           </a:p>
-          <a:p/>
+          <a:p>
+            <a:endParaRPr/>
+          </a:p>
           <a:p>
             <a:r>
               <a:t>(Cue: One sentence, then move on. Q&amp;A backup: predictions were made before the run; the one miss was SA (expected bigger gains) — exponential problems shrug at factors of two.)</a:t>
@@ -585,13 +614,17 @@
               <a:t>[~45 s]</a:t>
             </a:r>
           </a:p>
-          <a:p/>
+          <a:p>
+            <a:endParaRPr/>
+          </a:p>
           <a:p>
             <a:r>
               <a:t>To conclude. Inference was the story: full propagation solved everything we generated, and cracked the reference puzzle without any search. Fewer nodes is not the same as less time. Simulated annealing beats hill climbing, confirming prior work — and hill climbing's failures are structural, stuck one step from the goal. Sparse boards turned out easier for solvers than for humans. Future work: generating unique-solution puzzles, arc consistency, and difficulty calibration. Thank you — we are happy to take questions.</a:t>
             </a:r>
           </a:p>
-          <a:p/>
+          <a:p>
+            <a:endParaRPr/>
+          </a:p>
           <a:p>
             <a:r>
               <a:t>(Cue: All three members should have spoken by now.)</a:t>
@@ -683,7 +716,9 @@
               <a:t>[not spoken]</a:t>
             </a:r>
           </a:p>
-          <a:p/>
+          <a:p>
+            <a:endParaRPr/>
+          </a:p>
           <a:p>
             <a:r>
               <a:t>(Cue: Present for completeness and Q&amp;A only.)</a:t>
@@ -772,18 +807,59 @@
           <a:lstStyle/>
           <a:p>
             <a:r>
+              <a:rPr dirty="0"/>
               <a:t>[~1 min]</a:t>
             </a:r>
           </a:p>
-          <a:p/>
-          <a:p>
-            <a:r>
-              <a:t>LightUp has three rules. You place light bulbs on white cells. Rule one: every white cell must be lit — a bulb lights its whole row and column until a wall blocks the light. Rule two: no bulb may shine on another bulb. Rule three: a numbered wall must have exactly that many bulbs next to it — exactly, not at most. In this small example the corner two forces both of its neighbors, and one more bulb finishes the board. One detail worth remembering: nothing in the rules says a puzzle has only one solution — uniqueness is a publishing convention, and that detail will come back in our results.</a:t>
-            </a:r>
-          </a:p>
-          <a:p/>
-          <a:p>
-            <a:r>
+          <a:p>
+            <a:endParaRPr dirty="0"/>
+          </a:p>
+          <a:p>
+            <a:r>
+              <a:rPr dirty="0" err="1"/>
+              <a:t>LightUp</a:t>
+            </a:r>
+            <a:r>
+              <a:rPr dirty="0"/>
+              <a:t> has three rules. You place light bulbs on white cells. Rule one: every white cell must be lit — a bulb lights its whole row and column until a wall blocks the light. Rule two: no bulb may shine on another bulb. Rule three: a numbered wall must have exactly that many bulbs next to it — exactly, not at most. In this small example the corner two forces both of its neighbors, and one more bulb finishes the board. </a:t>
+            </a:r>
+            <a:endParaRPr lang="en-US" dirty="0"/>
+          </a:p>
+          <a:p>
+            <a:endParaRPr lang="en-US" dirty="0"/>
+          </a:p>
+          <a:p>
+            <a:r>
+              <a:rPr b="1" dirty="0">
+                <a:solidFill>
+                  <a:srgbClr val="C00000"/>
+                </a:solidFill>
+              </a:rPr>
+              <a:t>One detail worth remembering</a:t>
+            </a:r>
+            <a:r>
+              <a:rPr dirty="0"/>
+              <a:t>: nothing in the rules says a puzzle has only one solution — uniqueness is a publishing convention</a:t>
+            </a:r>
+            <a:r>
+              <a:rPr lang="en-US" dirty="0"/>
+              <a:t>, </a:t>
+            </a:r>
+            <a:r>
+              <a:rPr lang="en-US" b="1" dirty="0"/>
+              <a:t>and that detail will come back in our results</a:t>
+            </a:r>
+            <a:r>
+              <a:rPr dirty="0"/>
+              <a:t>.</a:t>
+            </a:r>
+          </a:p>
+          <a:p>
+            <a:endParaRPr dirty="0"/>
+          </a:p>
+          <a:p>
+            <a:r>
+              <a:rPr dirty="0"/>
               <a:t>(Cue: Point at the 3x3 while explaining. Do not dwell.)</a:t>
             </a:r>
           </a:p>
@@ -876,13 +952,19 @@
           <a:p/>
           <a:p>
             <a:r>
-              <a:t>Why is this a good AI problem? Three reasons. First, it is NP-complete — proven by reduction from circuit satisfiability — so no algorithm can be expected to scale forever, and cleverness has to earn its keep. Second, it is a very clean constraint-satisfaction problem: one yes-or-no variable per white cell. Third, it scales: our generator produces boards from three-by-three up to twenty-five-by-twenty-five with tunable difficulty, which gives us unlimited test data. Earlier work solved LightUp with SAT encodings, with local search, and with evolutionary algorithms — we compare directly against the local-search results later.</a:t>
+              <a:t>Why is this a good AI problem? Three reasons. First, it is NP-complete: it was proven in 2005 to be as hard as circuit satisfiability. In plain terms, the time needed to solve a puzzle grows explosively as the board grows, so every solver eventually meets a board it cannot finish. A better algorithm does not remove that wall — it only pushes it further away, and measuring how far each technique pushes it is what this project is about. Second, it is a very clean constraint-satisfaction problem: one yes-or-no variable per white cell. Third, it scales: our generator produces boards from three-by-three up to twenty-five-by-twenty-five with tunable difficulty, which gives us unlimited test data. Earlier work solved LightUp with SAT encodings, with local search, and with evolutionary algorithms — we compare directly against the local-search results later.</a:t>
             </a:r>
           </a:p>
           <a:p/>
           <a:p>
             <a:r>
               <a:t>(Cue: Prior work stays at one sentence — the course asks for brevity here.)</a:t>
+            </a:r>
+          </a:p>
+          <a:p/>
+          <a:p>
+            <a:r>
+              <a:t>(Q&amp;A trap: if NP-complete, why did you solve 25x25 in 20 ms? Because NP-completeness is a WORST-CASE statement. Puzzle-like instances carry a lot of structure, and inference exploits it; the hard instances the theory guarantees exist are not the ones a puzzle generator usually produces.)</a:t>
             </a:r>
           </a:p>
         </p:txBody>
@@ -971,13 +1053,17 @@
               <a:t>[~45 s]</a:t>
             </a:r>
           </a:p>
-          <a:p/>
+          <a:p>
+            <a:endParaRPr/>
+          </a:p>
           <a:p>
             <a:r>
               <a:t>Our formulation: one binary variable per white cell — bulb or no bulb. The three rules become three families of counting constraints: every cell's line of sight must contain at least one bulb; every wall-free segment, at most one; every numbered wall, exactly its number. One design decision worth mentioning: 'lit' is not a variable. Whether a cell is lit follows entirely from where the bulbs are, so storing it as a state would only inflate the search space.</a:t>
             </a:r>
           </a:p>
-          <a:p/>
+          <a:p>
+            <a:endParaRPr/>
+          </a:p>
           <a:p>
             <a:r>
               <a:t>(Cue: Do not explain what a CSP is — covered in the course.)</a:t>
@@ -1069,13 +1155,17 @@
               <a:t>[~1 min]</a:t>
             </a:r>
           </a:p>
-          <a:p/>
+          <a:p>
+            <a:endParaRPr/>
+          </a:p>
           <a:p>
             <a:r>
               <a:t>We implemented five solvers in two families. On the left, complete search. Plain backtracking is the baseline — it re-checks the whole board at every step. Forward checking adds memory: placing a bulb immediately rules out every cell it sees. Full inference adds deduction, applied over and over: a satisfied clue blocks its remaining neighbors, a clue that needs all its remaining cells forces them, and a cell with only one possible light source left forces that source. Those are exactly the moves a human player makes. On the right, local search: hill climbing and simulated annealing start from a complete random placement and repair it, guided by a score that counts rule violations — zero violations means solved. Every solver reports the same statistics, so the comparison is fair.</a:t>
             </a:r>
           </a:p>
-          <a:p/>
+          <a:p>
+            <a:endParaRPr/>
+          </a:p>
           <a:p>
             <a:r>
               <a:t>(Cue: This slide is the experiment design in one picture.)</a:t>
@@ -1167,13 +1257,17 @@
               <a:t>[~45 s]</a:t>
             </a:r>
           </a:p>
-          <a:p/>
+          <a:p>
+            <a:endParaRPr/>
+          </a:p>
           <a:p>
             <a:r>
               <a:t>Everything is observable. This is our game — you can play it yourself, including the X marks human players use for notes. The same window animates any solver: in this screenshot the naive solver is mid-search on a ten-by-ten — the red frame is a conflict it just hit, and the status bar shows it has already tried eighty-eight thousand nodes. This replay tool is how we debugged the solvers, and honestly, how we came to understand them.</a:t>
             </a:r>
           </a:p>
-          <a:p/>
+          <a:p>
+            <a:endParaRPr/>
+          </a:p>
           <a:p>
             <a:r>
               <a:t>(Cue: If Q&amp;A time allows, a 20-second live solve beats this slide — have the game open in a background window. Never show code.)</a:t>
@@ -1265,7 +1359,9 @@
               <a:t>[~45 s]</a:t>
             </a:r>
           </a:p>
-          <a:p/>
+          <a:p>
+            <a:endParaRPr/>
+          </a:p>
           <a:p>
             <a:r>
               <a:t>The experiment: five board sizes from seven to twenty-five, three difficulty presets from clue-dense to sparse, five seeded instances per combination — seventy-five unique puzzles — and every solver gets identical puzzles with a five-second budget: three hundred seventy-five runs. Everything is seeded, so every number that follows is reproducible. And one principle: we judge correctness by the rules themselves, never by comparing to a stored answer, because a board can have several legal solutions.</a:t>
@@ -1357,13 +1453,17 @@
               <a:t>[~1.5 min]</a:t>
             </a:r>
           </a:p>
-          <a:p/>
+          <a:p>
+            <a:endParaRPr/>
+          </a:p>
           <a:p>
             <a:r>
               <a:t>So, what does inference buy? Two headline numbers. On the published seven-by-seven, the naive solver needs three hundred and eight search nodes. Forward checking needs twelve. Full inference needs zero — the puzzle is solved entirely by deduction, no search at all. And that makes sense: publishers design puzzles that humans can deduce. Across the whole sweep, full inference solved all seventy-five instances — the only solver with a perfect record. The charts show the scaling: the naive curve leaves the picture after eighteen-by-eighteen — it solves nothing at twenty-five — while both smart variants stay one to two orders of magnitude lower. One honest nuance: full inference always expands about half the nodes of forward checking, but that only saves time when there is something to deduce. On clue-dense boards it is up to thirty-five times faster; on the sparse boards in this chart, forward checking wins, because propagation is an investment paid at every node.</a:t>
             </a:r>
           </a:p>
-          <a:p/>
+          <a:p>
+            <a:endParaRPr/>
+          </a:p>
           <a:p>
             <a:r>
               <a:t>(Cue: THE core slide. Say 308 -&gt; 12 -&gt; 0 slowly. If asked why fig 1 favours fc: it plots hard instances only.)</a:t>
@@ -1455,13 +1555,17 @@
               <a:t>[~1.5 min]</a:t>
             </a:r>
           </a:p>
-          <a:p/>
+          <a:p>
+            <a:endParaRPr/>
+          </a:p>
           <a:p>
             <a:r>
               <a:t>Now the other paradigm. This chart shows the solve rate within five seconds on hard instances. Simulated annealing clearly beats hill climbing everywhere — nineteen out of twenty-five versus eleven — which independently reproduces the published result of Perera and colleagues. Why does hill climbing fail? It gets stuck. In one twenty-second run it restarted twelve and a half thousand times and ended every attempt exactly one violation away from the goal. That is a local optimum in its purest form — and annealing's willingness to temporarily accept worse states is precisely what escapes it. Overall, though, within this budget, complete search with inference dominated local search at every size we tested. And one structural caveat: local search can never prove a board unsolvable.</a:t>
             </a:r>
           </a:p>
-          <a:p/>
+          <a:p>
+            <a:endParaRPr/>
+          </a:p>
           <a:p>
             <a:r>
               <a:t>(Cue: The one-violation-away story is the local-optimum concept made concrete — deliver it as a story.)</a:t>
@@ -5719,7 +5823,23 @@
                 <a:ea typeface="Calibri" pitchFamily="34" charset="-122"/>
                 <a:cs typeface="Calibri" pitchFamily="34" charset="-120"/>
               </a:rPr>
-              <a:t>Every white cell must be lit. A bulb lights its whole row and column until a wall blocks it.</a:t>
+              <a:t>Every white cell must be lit. </a:t>
+            </a:r>
+          </a:p>
+          <a:p>
+            <a:pPr marL="0" indent="0">
+              <a:buNone/>
+            </a:pPr>
+            <a:r>
+              <a:rPr lang="en-US" sz="1500" dirty="0">
+                <a:solidFill>
+                  <a:srgbClr val="F2EFE7"/>
+                </a:solidFill>
+                <a:latin typeface="Calibri" pitchFamily="34" charset="0"/>
+                <a:ea typeface="Calibri" pitchFamily="34" charset="-122"/>
+                <a:cs typeface="Calibri" pitchFamily="34" charset="-120"/>
+              </a:rPr>
+              <a:t>A bulb lights its whole row and column until a wall blocks it.</a:t>
             </a:r>
             <a:endParaRPr lang="en-US" sz="1800" dirty="0"/>
           </a:p>
@@ -5831,7 +5951,23 @@
                 <a:ea typeface="Calibri" pitchFamily="34" charset="-122"/>
                 <a:cs typeface="Calibri" pitchFamily="34" charset="-120"/>
               </a:rPr>
-              <a:t>A numbered wall must touch exactly that many bulbs. Plain walls constrain nothing.</a:t>
+              <a:t>A numbered wall must touch exactly that many bulbs. </a:t>
+            </a:r>
+          </a:p>
+          <a:p>
+            <a:pPr marL="0" indent="0">
+              <a:buNone/>
+            </a:pPr>
+            <a:r>
+              <a:rPr lang="en-US" sz="1500" dirty="0">
+                <a:solidFill>
+                  <a:srgbClr val="F2EFE7"/>
+                </a:solidFill>
+                <a:latin typeface="Calibri" pitchFamily="34" charset="0"/>
+                <a:ea typeface="Calibri" pitchFamily="34" charset="-122"/>
+                <a:cs typeface="Calibri" pitchFamily="34" charset="-120"/>
+              </a:rPr>
+              <a:t>Plain walls constrain nothing.</a:t>
             </a:r>
             <a:endParaRPr lang="en-US" sz="1800" dirty="0"/>
           </a:p>
@@ -5870,7 +6006,23 @@
                 <a:ea typeface="Calibri" pitchFamily="34" charset="-122"/>
                 <a:cs typeface="Calibri" pitchFamily="34" charset="-120"/>
               </a:rPr>
-              <a:t>Uniqueness of the solution is a publishing convention — not a rule. The rules define a constraint-satisfaction problem.</a:t>
+              <a:t>Uniqueness of the solution is a publishing convention — not a rule. </a:t>
+            </a:r>
+          </a:p>
+          <a:p>
+            <a:pPr marL="0" indent="0">
+              <a:buNone/>
+            </a:pPr>
+            <a:r>
+              <a:rPr lang="en-US" sz="1300" i="1" dirty="0">
+                <a:solidFill>
+                  <a:srgbClr val="A9A6B0"/>
+                </a:solidFill>
+                <a:latin typeface="Calibri" pitchFamily="34" charset="0"/>
+                <a:ea typeface="Calibri" pitchFamily="34" charset="-122"/>
+                <a:cs typeface="Calibri" pitchFamily="34" charset="-120"/>
+              </a:rPr>
+              <a:t>The rules define a constraint-satisfaction problem.</a:t>
             </a:r>
             <a:endParaRPr lang="en-US" sz="1300" dirty="0"/>
           </a:p>
@@ -6662,6 +6814,10 @@
           </a:solidFill>
           <a:ln/>
         </p:spPr>
+        <p:txBody>
+          <a:bodyPr/>
+          <a:p/>
+        </p:txBody>
       </p:sp>
       <p:sp>
         <p:nvSpPr>
@@ -6713,7 +6869,23 @@
                 <a:ea typeface="Calibri" pitchFamily="34" charset="-122"/>
                 <a:cs typeface="Calibri" pitchFamily="34" charset="-120"/>
               </a:rPr>
-              <a:t>Proven by reduction from Circuit-SAT (McPhail 2005). Worst-case exponential — cleverness must earn its keep.</a:t>
+              <a:t>Proven by reduction from Circuit-SAT (McPhail 2005). </a:t>
+            </a:r>
+          </a:p>
+          <a:p>
+            <a:pPr marL="0" indent="0">
+              <a:buNone/>
+            </a:pPr>
+            <a:r>
+              <a:rPr lang="en-US" sz="1400" dirty="0">
+                <a:solidFill>
+                  <a:srgbClr val="F2EFE7"/>
+                </a:solidFill>
+                <a:latin typeface="Calibri" pitchFamily="34" charset="0"/>
+                <a:ea typeface="Calibri" pitchFamily="34" charset="-122"/>
+                <a:cs typeface="Calibri" pitchFamily="34" charset="-120"/>
+              </a:rPr>
+              <a:t>Solving time grows exponentially in the worst case — a better algorithm pushes the limit further, it cannot remove it.</a:t>
             </a:r>
             <a:endParaRPr lang="en-US" sz="1900" dirty="0"/>
           </a:p>
@@ -6740,6 +6912,10 @@
           </a:solidFill>
           <a:ln/>
         </p:spPr>
+        <p:txBody>
+          <a:bodyPr/>
+          <a:p/>
+        </p:txBody>
       </p:sp>
       <p:sp>
         <p:nvSpPr>
@@ -6818,6 +6994,10 @@
           </a:solidFill>
           <a:ln/>
         </p:spPr>
+        <p:txBody>
+          <a:bodyPr/>
+          <a:p/>
+        </p:txBody>
       </p:sp>
       <p:sp>
         <p:nvSpPr>

</xml_diff>

<commit_message>
Slide 3: prior work now names constraint programming, not evolutionary
CSP is our main solver family and was missing from the prior-work line,
while evolutionary algorithms are neither implemented nor built on.
Replaced with Celik et al. 2009 (RCRA), which models Akari in both ASP
and CP - the explicit constraint-programming precedent for this puzzle.
Also drops the "compare directly" overclaim: we reproduce the published
local-search finding on our own instances, we do not rerun their
benchmark.

report.tex gains the Celik bibitem; report-notes.md records both it and
the framing of Pulles as our (unlabelled) CSP precedent.

Citation, venue and scope verified from two independent sources; the
paper's internal modelling was not readable here, so it is marked
READ BEFORE CITING.

Co-Authored-By: Claude Fable 5 <noreply@anthropic.com>
</commit_message>
<xml_diff>
--- a/docs/presentation.pptx
+++ b/docs/presentation.pptx
@@ -952,7 +952,7 @@
           <a:p/>
           <a:p>
             <a:r>
-              <a:t>Why is this a good AI problem? Three reasons. First, it is NP-complete: it was proven in 2005 to be as hard as circuit satisfiability. In plain terms, the time needed to solve a puzzle grows explosively as the board grows, so every solver eventually meets a board it cannot finish. A better algorithm does not remove that wall — it only pushes it further away, and measuring how far each technique pushes it is what this project is about. Second, it is a very clean constraint-satisfaction problem: one yes-or-no variable per white cell. Third, it scales: our generator produces boards from three-by-three up to twenty-five-by-twenty-five with tunable difficulty, which gives us unlimited test data. Earlier work solved LightUp with SAT encodings, with local search, and with evolutionary algorithms — we compare directly against the local-search results later.</a:t>
+              <a:t>Why is this a good AI problem? Three reasons. First, it is NP-complete: it was proven in 2005 to be as hard as circuit satisfiability. Second, it is a very clean constraint-satisfaction problem: one binary variable per white cell. Third, it scales: our generator produces boards from three-by-three up to twenty-five-by-twenty-five with tunable difficulty, which gives us unlimited test data. Earlier work solved LightUp three ways: by translating it into SAT, by modelling it as a constraint problem, and with local search. Our two solver families follow the last two — and later we check whether the published local-search finding still holds on our own instances.</a:t>
             </a:r>
           </a:p>
           <a:p/>
@@ -6816,7 +6816,10 @@
         </p:spPr>
         <p:txBody>
           <a:bodyPr/>
-          <a:p/>
+          <a:lstStyle/>
+          <a:p>
+            <a:endParaRPr/>
+          </a:p>
         </p:txBody>
       </p:sp>
       <p:sp>
@@ -6885,7 +6888,7 @@
                 <a:ea typeface="Calibri" pitchFamily="34" charset="-122"/>
                 <a:cs typeface="Calibri" pitchFamily="34" charset="-120"/>
               </a:rPr>
-              <a:t>Solving time grows exponentially in the worst case — a better algorithm pushes the limit further, it cannot remove it.</a:t>
+              <a:t>Solving time grows exponentially in the worst case.</a:t>
             </a:r>
             <a:endParaRPr lang="en-US" sz="1900" dirty="0"/>
           </a:p>
@@ -6914,7 +6917,10 @@
         </p:spPr>
         <p:txBody>
           <a:bodyPr/>
-          <a:p/>
+          <a:lstStyle/>
+          <a:p>
+            <a:endParaRPr/>
+          </a:p>
         </p:txBody>
       </p:sp>
       <p:sp>
@@ -6996,7 +7002,10 @@
         </p:spPr>
         <p:txBody>
           <a:bodyPr/>
-          <a:p/>
+          <a:lstStyle/>
+          <a:p>
+            <a:endParaRPr/>
+          </a:p>
         </p:txBody>
       </p:sp>
       <p:sp>
@@ -7099,7 +7108,7 @@
                 <a:ea typeface="Calibri" pitchFamily="34" charset="-122"/>
                 <a:cs typeface="Calibri" pitchFamily="34" charset="-120"/>
               </a:rPr>
-              <a:t>SAT encoding + backtracking (Pulles 2021) · hill climbing, simulated annealing, neural networks (Perera et al. 2021) · evolutionary algorithms (Salcedo-Sanz et al. 2009).</a:t>
+              <a:t>SAT encoding + backtracking (Pulles 2021) · constraint programming on grid puzzles incl. Akari (Çelik et al. 2009) · hill climbing, simulated annealing, neural networks (Perera et al. 2021).</a:t>
             </a:r>
             <a:endParaRPr lang="en-US" sz="1400" dirty="0"/>
           </a:p>

</xml_diff>

<commit_message>
Future work: drop arc consistency, add our own SAT route; sync notes
Slide 12 bullet and spoken note now propose a CNF encoding plus a DPLL
solver we write ourselves (Pulles used Z3; libraries are not allowed
here), instead of AC-3/MAC.  The arc-consistency item was wrong: for
at-most-one constraints over booleans, forward checking already achieves
arc consistency, and the full-inference solver already maintains
generalized arc consistency on all three constraint families - so it
proposed something weaker than what was shipped.

Adds docs/sync_speaker_notes.py, which regenerates speaker-notes.md from
the deck's notes so the two cannot drift; the pptx is now the source of
truth.  Parser handles multi-paragraph spoken text, several parenthetical
blocks per slide (stage cue plus Q&A note), and wrapped slide titles.

Co-Authored-By: Claude Fable 5 <noreply@anthropic.com>
</commit_message>
<xml_diff>
--- a/docs/presentation.pptx
+++ b/docs/presentation.pptx
@@ -415,15 +415,25 @@
           <a:lstStyle/>
           <a:p>
             <a:r>
+              <a:rPr dirty="0"/>
               <a:t>[~1 min]</a:t>
             </a:r>
           </a:p>
           <a:p>
-            <a:endParaRPr/>
-          </a:p>
-          <a:p>
-            <a:r>
-              <a:t>What makes an instance hard? Here we got a genuine surprise. Our hard preset — few walls, few clues — is hard for humans, but often faster for solvers: fewer clues means more valid solutions, and finding any one of them is easier. Hill climbing shows the mirror image: at fourteen-by-fourteen it solved nothing at easy or medium density, but sometimes cracked the sparse boards — dense clues create exactly the local optima that trap it. So our difficulty presets model human difficulty, not search difficulty — and calibrating them by measured effort is future work.</a:t>
+            <a:endParaRPr dirty="0"/>
+          </a:p>
+          <a:p>
+            <a:r>
+              <a:rPr dirty="0"/>
+              <a:t>What makes an instance hard? Here we got a genuine surprise. Our hard preset — few walls, few clues — is hard for humans, but often faster for solvers: fewer clues means more valid solutions, and finding any one of them is easier. Hill climbing shows the mirror image: at fourteen-by-fourteen it solved nothing at easy or medium density, but sometimes cracked the sparse boards — dense clues create exactly the local optima that trap it. So our difficulty presets model human difficulty, not search difficult</a:t>
+            </a:r>
+            <a:r>
+              <a:rPr lang="en-US" dirty="0"/>
+              <a:t>y</a:t>
+            </a:r>
+            <a:r>
+              <a:rPr dirty="0"/>
+              <a:t>.</a:t>
             </a:r>
           </a:p>
         </p:txBody>
@@ -509,22 +519,25 @@
           <a:lstStyle/>
           <a:p>
             <a:r>
+              <a:rPr dirty="0"/>
               <a:t>[~20 s]</a:t>
             </a:r>
           </a:p>
           <a:p>
-            <a:endParaRPr/>
-          </a:p>
-          <a:p>
-            <a:r>
+            <a:endParaRPr dirty="0"/>
+          </a:p>
+          <a:p>
+            <a:r>
+              <a:rPr dirty="0"/>
               <a:t>One robustness check: we re-ran the entire sweep with double the budget — almost nothing changed, and hill climbing gained exactly zero — so the ranking you have seen is structural, not an artifact of the timeout.</a:t>
             </a:r>
           </a:p>
           <a:p>
-            <a:endParaRPr/>
-          </a:p>
-          <a:p>
-            <a:r>
+            <a:endParaRPr dirty="0"/>
+          </a:p>
+          <a:p>
+            <a:r>
+              <a:rPr dirty="0"/>
               <a:t>(Cue: One sentence, then move on. Q&amp;A backup: predictions were made before the run; the one miss was SA (expected bigger gains) — exponential problems shrug at factors of two.)</a:t>
             </a:r>
           </a:p>
@@ -614,17 +627,13 @@
               <a:t>[~45 s]</a:t>
             </a:r>
           </a:p>
-          <a:p>
-            <a:endParaRPr/>
-          </a:p>
-          <a:p>
-            <a:r>
-              <a:t>To conclude. Inference was the story: full propagation solved everything we generated, and cracked the reference puzzle without any search. Fewer nodes is not the same as less time. Simulated annealing beats hill climbing, confirming prior work — and hill climbing's failures are structural, stuck one step from the goal. Sparse boards turned out easier for solvers than for humans. Future work: generating unique-solution puzzles, arc consistency, and difficulty calibration. Thank you — we are happy to take questions.</a:t>
-            </a:r>
-          </a:p>
-          <a:p>
-            <a:endParaRPr/>
-          </a:p>
+          <a:p/>
+          <a:p>
+            <a:r>
+              <a:t>To conclude. Inference was the story: full propagation solved everything we generated, and cracked the reference puzzle without any search. Fewer nodes is not the same as less time. Simulated annealing beats hill climbing, confirming prior work — and hill climbing's failures are structural, stuck one step from the goal. Sparse boards turned out easier for solvers than for humans. Future work: generating puzzles with a guaranteed unique solution, writing our own SAT solver so we can compare a clause-based formulation against our constraint-based one, and calibrating difficulty from measured search effort rather than from clue density. Thank you — we are happy to take questions.</a:t>
+            </a:r>
+          </a:p>
+          <a:p/>
           <a:p>
             <a:r>
               <a:t>(Cue: All three members should have spoken by now.)</a:t>
@@ -946,25 +955,51 @@
           <a:lstStyle/>
           <a:p>
             <a:r>
+              <a:rPr dirty="0"/>
               <a:t>[~1 min]</a:t>
             </a:r>
           </a:p>
-          <a:p/>
-          <a:p>
-            <a:r>
-              <a:t>Why is this a good AI problem? Three reasons. First, it is NP-complete: it was proven in 2005 to be as hard as circuit satisfiability. Second, it is a very clean constraint-satisfaction problem: one binary variable per white cell. Third, it scales: our generator produces boards from three-by-three up to twenty-five-by-twenty-five with tunable difficulty, which gives us unlimited test data. Earlier work solved LightUp three ways: by translating it into SAT, by modelling it as a constraint problem, and with local search. Our two solver families follow the last two — and later we check whether the published local-search finding still holds on our own instances.</a:t>
-            </a:r>
-          </a:p>
-          <a:p/>
-          <a:p>
-            <a:r>
+          <a:p>
+            <a:endParaRPr dirty="0"/>
+          </a:p>
+          <a:p>
+            <a:r>
+              <a:rPr dirty="0"/>
+              <a:t>Why is this a good AI problem? Three reasons. First, it is NP-complete: it was proven in 2005 to be as hard as circuit satisfiability. Second, it is a very clean constraint-satisfaction problem: one binary variable per white cell. Third, it scales: our generator produces boards from three-by-three up to twenty-five-by-twenty-five with tunable difficulty, which gives us unlimited test data. Earlier work solved </a:t>
+            </a:r>
+            <a:r>
+              <a:rPr dirty="0" err="1"/>
+              <a:t>LightUp</a:t>
+            </a:r>
+            <a:r>
+              <a:rPr dirty="0"/>
+              <a:t> three ways: by translating it into SAT, by modelling it as a constraint problem, and with local search. Our two solver families follow the last two — and later we check whether the published local-search finding still holds on our own instances.</a:t>
+            </a:r>
+          </a:p>
+          <a:p>
+            <a:endParaRPr dirty="0"/>
+          </a:p>
+          <a:p>
+            <a:r>
+              <a:rPr dirty="0"/>
               <a:t>(Cue: Prior work stays at one sentence — the course asks for brevity here.)</a:t>
             </a:r>
           </a:p>
-          <a:p/>
-          <a:p>
-            <a:r>
-              <a:t>(Q&amp;A trap: if NP-complete, why did you solve 25x25 in 20 ms? Because NP-completeness is a WORST-CASE statement. Puzzle-like instances carry a lot of structure, and inference exploits it; the hard instances the theory guarantees exist are not the ones a puzzle generator usually produces.)</a:t>
+          <a:p>
+            <a:endParaRPr dirty="0"/>
+          </a:p>
+          <a:p>
+            <a:r>
+              <a:rPr dirty="0"/>
+              <a:t>(Q&amp;A trap: if NP-complete, why did you solve 25x25 in 20 </a:t>
+            </a:r>
+            <a:r>
+              <a:rPr dirty="0" err="1"/>
+              <a:t>ms</a:t>
+            </a:r>
+            <a:r>
+              <a:rPr dirty="0"/>
+              <a:t>? Because NP-completeness is a WORST-CASE statement. Puzzle-like instances carry a lot of structure, and inference exploits it; the hard instances the theory guarantees exist are not the ones a puzzle generator usually produces.)</a:t>
             </a:r>
           </a:p>
         </p:txBody>
@@ -1050,22 +1085,29 @@
           <a:lstStyle/>
           <a:p>
             <a:r>
+              <a:rPr dirty="0"/>
               <a:t>[~45 s]</a:t>
             </a:r>
           </a:p>
           <a:p>
-            <a:endParaRPr/>
-          </a:p>
-          <a:p>
-            <a:r>
-              <a:t>Our formulation: one binary variable per white cell — bulb or no bulb. The three rules become three families of counting constraints: every cell's line of sight must contain at least one bulb; every wall-free segment, at most one; every numbered wall, exactly its number. One design decision worth mentioning: 'lit' is not a variable. Whether a cell is lit follows entirely from where the bulbs are, so storing it as a state would only inflate the search space.</a:t>
-            </a:r>
-          </a:p>
-          <a:p>
-            <a:endParaRPr/>
-          </a:p>
-          <a:p>
-            <a:r>
+            <a:endParaRPr dirty="0"/>
+          </a:p>
+          <a:p>
+            <a:r>
+              <a:rPr dirty="0"/>
+              <a:t>Our formulation: one binary variable per white cell — bulb or no bulb. The three rules become three families of constraints: every cell's line of sight must contain at least one bulb; every wall-free segment, at most one; every numbered wall, exactly its number. Whether a cell is lit follows entirely from where the bulbs are</a:t>
+            </a:r>
+            <a:r>
+              <a:rPr lang="en-US" dirty="0"/>
+              <a:t>.</a:t>
+            </a:r>
+          </a:p>
+          <a:p>
+            <a:endParaRPr dirty="0"/>
+          </a:p>
+          <a:p>
+            <a:r>
+              <a:rPr dirty="0"/>
               <a:t>(Cue: Do not explain what a CSP is — covered in the course.)</a:t>
             </a:r>
           </a:p>
@@ -1152,22 +1194,25 @@
           <a:lstStyle/>
           <a:p>
             <a:r>
+              <a:rPr dirty="0"/>
               <a:t>[~1 min]</a:t>
             </a:r>
           </a:p>
           <a:p>
-            <a:endParaRPr/>
-          </a:p>
-          <a:p>
-            <a:r>
+            <a:endParaRPr dirty="0"/>
+          </a:p>
+          <a:p>
+            <a:r>
+              <a:rPr dirty="0"/>
               <a:t>We implemented five solvers in two families. On the left, complete search. Plain backtracking is the baseline — it re-checks the whole board at every step. Forward checking adds memory: placing a bulb immediately rules out every cell it sees. Full inference adds deduction, applied over and over: a satisfied clue blocks its remaining neighbors, a clue that needs all its remaining cells forces them, and a cell with only one possible light source left forces that source. Those are exactly the moves a human player makes. On the right, local search: hill climbing and simulated annealing start from a complete random placement and repair it, guided by a score that counts rule violations — zero violations means solved. Every solver reports the same statistics, so the comparison is fair.</a:t>
             </a:r>
           </a:p>
           <a:p>
-            <a:endParaRPr/>
-          </a:p>
-          <a:p>
-            <a:r>
+            <a:endParaRPr dirty="0"/>
+          </a:p>
+          <a:p>
+            <a:r>
+              <a:rPr dirty="0"/>
               <a:t>(Cue: This slide is the experiment design in one picture.)</a:t>
             </a:r>
           </a:p>
@@ -1254,22 +1299,25 @@
           <a:lstStyle/>
           <a:p>
             <a:r>
+              <a:rPr dirty="0"/>
               <a:t>[~45 s]</a:t>
             </a:r>
           </a:p>
           <a:p>
-            <a:endParaRPr/>
-          </a:p>
-          <a:p>
-            <a:r>
+            <a:endParaRPr dirty="0"/>
+          </a:p>
+          <a:p>
+            <a:r>
+              <a:rPr dirty="0"/>
               <a:t>Everything is observable. This is our game — you can play it yourself, including the X marks human players use for notes. The same window animates any solver: in this screenshot the naive solver is mid-search on a ten-by-ten — the red frame is a conflict it just hit, and the status bar shows it has already tried eighty-eight thousand nodes. This replay tool is how we debugged the solvers, and honestly, how we came to understand them.</a:t>
             </a:r>
           </a:p>
           <a:p>
-            <a:endParaRPr/>
-          </a:p>
-          <a:p>
-            <a:r>
+            <a:endParaRPr dirty="0"/>
+          </a:p>
+          <a:p>
+            <a:r>
+              <a:rPr dirty="0"/>
               <a:t>(Cue: If Q&amp;A time allows, a 20-second live solve beats this slide — have the game open in a background window. Never show code.)</a:t>
             </a:r>
           </a:p>
@@ -1356,14 +1404,16 @@
           <a:lstStyle/>
           <a:p>
             <a:r>
+              <a:rPr dirty="0"/>
               <a:t>[~45 s]</a:t>
             </a:r>
           </a:p>
           <a:p>
-            <a:endParaRPr/>
-          </a:p>
-          <a:p>
-            <a:r>
+            <a:endParaRPr dirty="0"/>
+          </a:p>
+          <a:p>
+            <a:r>
+              <a:rPr dirty="0"/>
               <a:t>The experiment: five board sizes from seven to twenty-five, three difficulty presets from clue-dense to sparse, five seeded instances per combination — seventy-five unique puzzles — and every solver gets identical puzzles with a five-second budget: three hundred seventy-five runs. Everything is seeded, so every number that follows is reproducible. And one principle: we judge correctness by the rules themselves, never by comparing to a stored answer, because a board can have several legal solutions.</a:t>
             </a:r>
           </a:p>
@@ -1450,23 +1500,34 @@
           <a:lstStyle/>
           <a:p>
             <a:r>
+              <a:rPr dirty="0"/>
               <a:t>[~1.5 min]</a:t>
             </a:r>
           </a:p>
           <a:p>
-            <a:endParaRPr/>
-          </a:p>
-          <a:p>
-            <a:r>
+            <a:endParaRPr dirty="0"/>
+          </a:p>
+          <a:p>
+            <a:r>
+              <a:rPr dirty="0"/>
               <a:t>So, what does inference buy? Two headline numbers. On the published seven-by-seven, the naive solver needs three hundred and eight search nodes. Forward checking needs twelve. Full inference needs zero — the puzzle is solved entirely by deduction, no search at all. And that makes sense: publishers design puzzles that humans can deduce. Across the whole sweep, full inference solved all seventy-five instances — the only solver with a perfect record. The charts show the scaling: the naive curve leaves the picture after eighteen-by-eighteen — it solves nothing at twenty-five — while both smart variants stay one to two orders of magnitude lower. One honest nuance: full inference always expands about half the nodes of forward checking, but that only saves time when there is something to deduce. On clue-dense boards it is up to thirty-five times faster; on the sparse boards in this chart, forward checking wins, because propagation is an investment paid at every node.</a:t>
             </a:r>
           </a:p>
           <a:p>
-            <a:endParaRPr/>
-          </a:p>
-          <a:p>
-            <a:r>
-              <a:t>(Cue: THE core slide. Say 308 -&gt; 12 -&gt; 0 slowly. If asked why fig 1 favours fc: it plots hard instances only.)</a:t>
+            <a:endParaRPr dirty="0"/>
+          </a:p>
+          <a:p>
+            <a:r>
+              <a:rPr dirty="0"/>
+              <a:t>(Cue: THE core slide. Say 308 -&gt; 12 -&gt; 0 slowly. If asked why fig 1 </a:t>
+            </a:r>
+            <a:r>
+              <a:rPr dirty="0" err="1"/>
+              <a:t>favours</a:t>
+            </a:r>
+            <a:r>
+              <a:rPr dirty="0"/>
+              <a:t> fc: it plots hard instances only.)</a:t>
             </a:r>
           </a:p>
         </p:txBody>
@@ -1552,22 +1613,25 @@
           <a:lstStyle/>
           <a:p>
             <a:r>
+              <a:rPr dirty="0"/>
               <a:t>[~1.5 min]</a:t>
             </a:r>
           </a:p>
           <a:p>
-            <a:endParaRPr/>
-          </a:p>
-          <a:p>
-            <a:r>
+            <a:endParaRPr dirty="0"/>
+          </a:p>
+          <a:p>
+            <a:r>
+              <a:rPr dirty="0"/>
               <a:t>Now the other paradigm. This chart shows the solve rate within five seconds on hard instances. Simulated annealing clearly beats hill climbing everywhere — nineteen out of twenty-five versus eleven — which independently reproduces the published result of Perera and colleagues. Why does hill climbing fail? It gets stuck. In one twenty-second run it restarted twelve and a half thousand times and ended every attempt exactly one violation away from the goal. That is a local optimum in its purest form — and annealing's willingness to temporarily accept worse states is precisely what escapes it. Overall, though, within this budget, complete search with inference dominated local search at every size we tested. And one structural caveat: local search can never prove a board unsolvable.</a:t>
             </a:r>
           </a:p>
           <a:p>
-            <a:endParaRPr/>
-          </a:p>
-          <a:p>
-            <a:r>
+            <a:endParaRPr dirty="0"/>
+          </a:p>
+          <a:p>
+            <a:r>
+              <a:rPr dirty="0"/>
               <a:t>(Cue: The one-violation-away story is the local-optimum concept made concrete — deliver it as a story.)</a:t>
             </a:r>
           </a:p>
@@ -5336,7 +5400,7 @@
                 <a:ea typeface="Calibri" pitchFamily="34" charset="-122"/>
                 <a:cs typeface="Calibri" pitchFamily="34" charset="-120"/>
               </a:rPr>
-              <a:t>Future work: uniqueness-filtered generation, AC-3 / MAC on the binary constraints, difficulty calibration from measured search effort.</a:t>
+              <a:t>Future work: uniqueness-filtered generation; our own SAT route — a CNF encoding plus a DPLL solver we write ourselves — to compare a clause-based formulation against our constraint-based one; and difficulty calibration from measured search effort.</a:t>
             </a:r>
             <a:endParaRPr lang="en-US" sz="1500" dirty="0"/>
           </a:p>
@@ -5363,6 +5427,10 @@
           </a:solidFill>
           <a:ln/>
         </p:spPr>
+        <p:txBody>
+          <a:bodyPr/>
+          <a:p/>
+        </p:txBody>
       </p:sp>
       <p:sp>
         <p:nvSpPr>
@@ -7073,7 +7141,7 @@
         <p:spPr>
           <a:xfrm>
             <a:off x="640080" y="4206240"/>
-            <a:ext cx="10972800" cy="914400"/>
+            <a:ext cx="10972800" cy="1463040"/>
           </a:xfrm>
           <a:prstGeom prst="rect">
             <a:avLst/>
@@ -7097,8 +7165,13 @@
                 <a:ea typeface="Arial" pitchFamily="34" charset="-122"/>
                 <a:cs typeface="Arial" pitchFamily="34" charset="-120"/>
               </a:rPr>
-              <a:t>Existing approaches (briefly): </a:t>
-            </a:r>
+              <a:t>Existing approaches: </a:t>
+            </a:r>
+          </a:p>
+          <a:p>
+            <a:pPr marL="0" indent="0">
+              <a:buNone/>
+            </a:pPr>
             <a:r>
               <a:rPr lang="en-US" sz="1400" dirty="0">
                 <a:solidFill>
@@ -7108,7 +7181,39 @@
                 <a:ea typeface="Calibri" pitchFamily="34" charset="-122"/>
                 <a:cs typeface="Calibri" pitchFamily="34" charset="-120"/>
               </a:rPr>
-              <a:t>SAT encoding + backtracking (Pulles 2021) · constraint programming on grid puzzles incl. Akari (Çelik et al. 2009) · hill climbing, simulated annealing, neural networks (Perera et al. 2021).</a:t>
+              <a:t>· SAT encoding + backtracking (Pulles 2021) </a:t>
+            </a:r>
+          </a:p>
+          <a:p>
+            <a:pPr marL="0" indent="0">
+              <a:buNone/>
+            </a:pPr>
+            <a:r>
+              <a:rPr lang="en-US" sz="1400" dirty="0">
+                <a:solidFill>
+                  <a:srgbClr val="A9A6B0"/>
+                </a:solidFill>
+                <a:latin typeface="Calibri" pitchFamily="34" charset="0"/>
+                <a:ea typeface="Calibri" pitchFamily="34" charset="-122"/>
+                <a:cs typeface="Calibri" pitchFamily="34" charset="-120"/>
+              </a:rPr>
+              <a:t>· constraint programming on grid puzzles incl. Akari (Çelik et al. 2009) </a:t>
+            </a:r>
+          </a:p>
+          <a:p>
+            <a:pPr marL="0" indent="0">
+              <a:buNone/>
+            </a:pPr>
+            <a:r>
+              <a:rPr lang="en-US" sz="1400" dirty="0">
+                <a:solidFill>
+                  <a:srgbClr val="A9A6B0"/>
+                </a:solidFill>
+                <a:latin typeface="Calibri" pitchFamily="34" charset="0"/>
+                <a:ea typeface="Calibri" pitchFamily="34" charset="-122"/>
+                <a:cs typeface="Calibri" pitchFamily="34" charset="-120"/>
+              </a:rPr>
+              <a:t>· hill climbing, simulated annealing, neural networks (Perera et al. 2021).</a:t>
             </a:r>
             <a:endParaRPr lang="en-US" sz="1400" dirty="0"/>
           </a:p>
@@ -7984,45 +8089,6 @@
       </p:graphicFrame>
       <p:sp>
         <p:nvSpPr>
-          <p:cNvPr id="4" name="Text 1"/>
-          <p:cNvSpPr/>
-          <p:nvPr/>
-        </p:nvSpPr>
-        <p:spPr>
-          <a:xfrm>
-            <a:off x="640080" y="5029200"/>
-            <a:ext cx="10881360" cy="548640"/>
-          </a:xfrm>
-          <a:prstGeom prst="rect">
-            <a:avLst/>
-          </a:prstGeom>
-          <a:noFill/>
-          <a:ln/>
-        </p:spPr>
-        <p:txBody>
-          <a:bodyPr wrap="square" lIns="0" tIns="0" rIns="0" bIns="0" rtlCol="0" anchor="ctr"/>
-          <a:lstStyle/>
-          <a:p>
-            <a:pPr marL="0" indent="0">
-              <a:buNone/>
-            </a:pPr>
-            <a:r>
-              <a:rPr lang="en-US" sz="1400" i="1" dirty="0">
-                <a:solidFill>
-                  <a:srgbClr val="A9A6B0"/>
-                </a:solidFill>
-                <a:latin typeface="Calibri" pitchFamily="34" charset="0"/>
-                <a:ea typeface="Calibri" pitchFamily="34" charset="-122"/>
-                <a:cs typeface="Calibri" pitchFamily="34" charset="-120"/>
-              </a:rPr>
-              <a:t>“Lit” is a derived property, not a cell state — it inflates nothing: lit(w) ⟺ a bulb exists in {w} ∪ sight(w).</a:t>
-            </a:r>
-            <a:endParaRPr lang="en-US" sz="1400" dirty="0"/>
-          </a:p>
-        </p:txBody>
-      </p:sp>
-      <p:sp>
-        <p:nvSpPr>
           <p:cNvPr id="6" name="Text 2"/>
           <p:cNvSpPr/>
           <p:nvPr/>
@@ -9609,7 +9675,23 @@
                 <a:ea typeface="Calibri" pitchFamily="34" charset="-122"/>
                 <a:cs typeface="Calibri" pitchFamily="34" charset="-120"/>
               </a:rPr>
-              <a:t>Naive BT leaves the chart after 18×18 (0 % solved at 25×25). Full inference always expands ~2× fewer nodes — but that saves time only where there is something to deduce: 35× faster on easy boards, slower on the sparse hard boards plotted here.</a:t>
+              <a:t>Naive BT leaves the chart after 18×18 (0 % solved at 25×25). Full inference always expands ~2× fewer nodes — but that saves time only where there is something to deduce: </a:t>
+            </a:r>
+          </a:p>
+          <a:p>
+            <a:pPr marL="0" indent="0">
+              <a:buNone/>
+            </a:pPr>
+            <a:r>
+              <a:rPr lang="en-US" sz="1150" i="1" dirty="0">
+                <a:solidFill>
+                  <a:srgbClr val="A9A6B0"/>
+                </a:solidFill>
+                <a:latin typeface="Calibri" pitchFamily="34" charset="0"/>
+                <a:ea typeface="Calibri" pitchFamily="34" charset="-122"/>
+                <a:cs typeface="Calibri" pitchFamily="34" charset="-120"/>
+              </a:rPr>
+              <a:t>35× faster on easy boards, slower on the sparse hard boards plotted here.</a:t>
             </a:r>
             <a:endParaRPr lang="en-US" sz="1150" dirty="0"/>
           </a:p>

</xml_diff>

<commit_message>
Slides: retitle slide 1 to "Light Up Akari with AI Search"
Author's edit to the deck. speaker-notes.md is generated from the notes
panes and carries the slide titles as its section headings, so it is
regenerated here to keep the two from drifting.

No other slide body or note changed.

Co-Authored-By: Claude Opus 5 <noreply@anthropic.com>
</commit_message>
<xml_diff>
--- a/docs/presentation.pptx
+++ b/docs/presentation.pptx
@@ -1596,7 +1596,9 @@
               <a:t>[~1 min]</a:t>
             </a:r>
           </a:p>
-          <a:p/>
+          <a:p>
+            <a:endParaRPr/>
+          </a:p>
           <a:p>
             <a:r>
               <a:t>What does inference buy? On the published seven-by-seven, full inference places every bulb by deduction - no search at all, where the naive solver needs hundreds of guesses. Publishers design puzzles humans can reason through, and our rules are those same steps.</a:t>
@@ -1617,7 +1619,9 @@
               <a:t>One nuance. Full inference always expands fewer nodes, but propagation is not free - it re-checks every clue at every node, even when nothing new comes out. On clue-rich boards that pays back. On the sparse boards plotted here it does not, and forward checking wins.</a:t>
             </a:r>
           </a:p>
-          <a:p/>
+          <a:p>
+            <a:endParaRPr/>
+          </a:p>
           <a:p>
             <a:r>
               <a:t>(Cue: THE core slide. Say ZERO slowly and let it land. Q&amp;A backup - the exact numbers on that puzzle are 308 naive, 12 forward checking, 0 full; the chart is a median over five GENERATED hard boards, where naive is 94.)</a:t>
@@ -4726,7 +4730,7 @@
                 <a:ea typeface="Arial" pitchFamily="34" charset="-122"/>
                 <a:cs typeface="Arial" pitchFamily="34" charset="-120"/>
               </a:rPr>
-              <a:t>Lighting Up Akari with </a:t>
+              <a:t>Light Up Akari with </a:t>
             </a:r>
           </a:p>
           <a:p>

</xml_diff>